<commit_message>
Add DIF - handwritten representation assignment
</commit_message>
<xml_diff>
--- a/Summary/training_review.pptx
+++ b/Summary/training_review.pptx
@@ -133,6 +133,64 @@
     </p:ext>
   </p:extLst>
 </p:presentation>
+</file>
+
+<file path=ppt/authors.xml><?xml version="1.0" encoding="utf-8"?>
+<p188:authorLst xmlns:a="http://schemas.openxmlformats.org/drawingml/2006/main" xmlns:r="http://schemas.openxmlformats.org/officeDocument/2006/relationships" xmlns:p188="http://schemas.microsoft.com/office/powerpoint/2018/8/main">
+  <p188:author id="{ADDC1805-C575-522E-8777-9E1DA016861C}" name="Aman Jalan" initials="AJ" userId="bf43d9433e811258" providerId="Windows Live"/>
+</p188:authorLst>
+</file>
+
+<file path=ppt/comments/modernComment_101_0.xml><?xml version="1.0" encoding="utf-8"?>
+<p188:cmLst xmlns:a="http://schemas.openxmlformats.org/drawingml/2006/main" xmlns:r="http://schemas.openxmlformats.org/officeDocument/2006/relationships" xmlns:p188="http://schemas.microsoft.com/office/powerpoint/2018/8/main">
+  <p188:cm id="{840DF4CD-DE00-5D46-A2B1-F03536443233}" authorId="{ADDC1805-C575-522E-8777-9E1DA016861C}" created="2026-06-11T09:09:07.951">
+    <ac:txMkLst xmlns:ac="http://schemas.microsoft.com/office/drawing/2013/main/command">
+      <pc:docMk xmlns:pc="http://schemas.microsoft.com/office/powerpoint/2013/main/command"/>
+      <pc:sldMk xmlns:pc="http://schemas.microsoft.com/office/powerpoint/2013/main/command" cId="0" sldId="257"/>
+      <ac:spMk id="8" creationId="{00000000-0000-0000-0000-000000000000}"/>
+      <ac:txMk cp="6" len="3">
+        <ac:context len="10" hash="88407680"/>
+      </ac:txMk>
+    </ac:txMkLst>
+    <p188:pos x="2419773" y="459458"/>
+    <p188:txBody>
+      <a:bodyPr/>
+      <a:lstStyle/>
+      <a:p>
+        <a:r>
+          <a:rPr lang="en-US"/>
+          <a:t>rewrite</a:t>
+        </a:r>
+      </a:p>
+    </p188:txBody>
+  </p188:cm>
+</p188:cmLst>
+</file>
+
+<file path=ppt/comments/modernComment_107_0.xml><?xml version="1.0" encoding="utf-8"?>
+<p188:cmLst xmlns:a="http://schemas.openxmlformats.org/drawingml/2006/main" xmlns:r="http://schemas.openxmlformats.org/officeDocument/2006/relationships" xmlns:p188="http://schemas.microsoft.com/office/powerpoint/2018/8/main">
+  <p188:cm id="{CAF872E0-D961-2549-B366-82541E2EFE33}" authorId="{ADDC1805-C575-522E-8777-9E1DA016861C}" created="2026-06-11T09:38:41.795">
+    <ac:txMkLst xmlns:ac="http://schemas.microsoft.com/office/drawing/2013/main/command">
+      <pc:docMk xmlns:pc="http://schemas.microsoft.com/office/powerpoint/2013/main/command"/>
+      <pc:sldMk xmlns:pc="http://schemas.microsoft.com/office/powerpoint/2013/main/command" cId="0" sldId="263"/>
+      <ac:spMk id="3" creationId="{00000000-0000-0000-0000-000000000000}"/>
+      <ac:txMk cp="7" len="45">
+        <ac:context len="53" hash="164944107"/>
+      </ac:txMk>
+    </ac:txMkLst>
+    <p188:pos x="7402286" y="492034"/>
+    <p188:txBody>
+      <a:bodyPr/>
+      <a:lstStyle/>
+      <a:p>
+        <a:r>
+          <a:rPr lang="en-US"/>
+          <a:t>handwritten exercise</a:t>
+        </a:r>
+      </a:p>
+    </p188:txBody>
+  </p188:cm>
+</p188:cmLst>
 </file>
 
 <file path=ppt/notesMasters/notesMaster1.xml><?xml version="1.0" encoding="utf-8"?>
@@ -14345,7 +14403,7 @@
                 <a:ea typeface="Calibri" pitchFamily="34" charset="-122"/>
                 <a:cs typeface="Calibri" pitchFamily="34" charset="-120"/>
               </a:rPr>
-              <a:t>Identify points that deviate structurally from the majority, not just statistically (Anomalies).</a:t>
+              <a:t>Identify points that deviate structurally from the majority (Anomalies).</a:t>
             </a:r>
             <a:endParaRPr lang="en-US" sz="1250" dirty="0"/>
           </a:p>
@@ -14462,7 +14520,18 @@
                 <a:ea typeface="Cambria" pitchFamily="34" charset="-122"/>
                 <a:cs typeface="Cambria" pitchFamily="34" charset="-120"/>
               </a:rPr>
-              <a:t>f : D → ℝᴿ</a:t>
+              <a:t>f : D → </a:t>
+            </a:r>
+            <a:r>
+              <a:rPr lang="en-US" sz="2200" b="1" dirty="0" err="1">
+                <a:solidFill>
+                  <a:srgbClr val="1B2A4A"/>
+                </a:solidFill>
+                <a:latin typeface="Cambria" pitchFamily="34" charset="0"/>
+                <a:ea typeface="Cambria" pitchFamily="34" charset="-122"/>
+                <a:cs typeface="Cambria" pitchFamily="34" charset="-120"/>
+              </a:rPr>
+              <a:t>ℝ</a:t>
             </a:r>
             <a:endParaRPr lang="en-US" sz="2200" dirty="0"/>
           </a:p>
@@ -14501,7 +14570,7 @@
                 <a:ea typeface="Calibri" pitchFamily="34" charset="-122"/>
                 <a:cs typeface="Calibri" pitchFamily="34" charset="-120"/>
               </a:rPr>
-              <a:t>D = {o₁, …, oₙ}   ·   Higher score = more anomalous</a:t>
+              <a:t>D E {o₁, …, oₙ}   Higher score = more anomalous</a:t>
             </a:r>
             <a:endParaRPr lang="en-US" sz="1100" dirty="0"/>
           </a:p>
@@ -14902,6 +14971,11 @@
   <p:clrMapOvr>
     <a:masterClrMapping/>
   </p:clrMapOvr>
+  <p:extLst>
+    <p:ext uri="{6950BFC3-D8DA-4A85-94F7-54DA5524770B}">
+      <p188:commentRel xmlns:p188="http://schemas.microsoft.com/office/powerpoint/2018/8/main" r:id="rId3"/>
+    </p:ext>
+  </p:extLst>
 </p:sld>
 </file>
 
@@ -27026,7 +27100,7 @@
           <p:nvPr/>
         </p:nvPicPr>
         <p:blipFill>
-          <a:blip r:embed="rId3"/>
+          <a:blip r:embed="rId4"/>
           <a:stretch>
             <a:fillRect/>
           </a:stretch>
@@ -27046,6 +27120,11 @@
   <p:clrMapOvr>
     <a:masterClrMapping/>
   </p:clrMapOvr>
+  <p:extLst>
+    <p:ext uri="{6950BFC3-D8DA-4A85-94F7-54DA5524770B}">
+      <p188:commentRel xmlns:p188="http://schemas.microsoft.com/office/powerpoint/2018/8/main" r:id="rId3"/>
+    </p:ext>
+  </p:extLst>
 </p:sld>
 </file>
 

</xml_diff>